<commit_message>
docs: update Flight Delay Prediction System presentation slides to reflect project features
</commit_message>
<xml_diff>
--- a/Flight_Delay_Prediction_System.pptx
+++ b/Flight_Delay_Prediction_System.pptx
@@ -4630,134 +4630,41 @@
           </a:bodyPr>
           <a:lstStyle/>
           <a:p>
-            <a:pPr marL="173355" marR="0" lvl="0" indent="-173355" rtl="0">
-              <a:lnSpc>
-                <a:spcPct val="100000"/>
-              </a:lnSpc>
-              <a:spcBef>
-                <a:spcPts val="0"/>
-              </a:spcBef>
-              <a:spcAft>
-                <a:spcPts val="800"/>
-              </a:spcAft>
-              <a:buFont typeface="Arial" panose="020B0604020202020204" pitchFamily="34" charset="0"/>
-              <a:buChar char="•"/>
-            </a:pPr>
             <a:r>
-              <a:rPr>
-                <a:sym typeface="+mn-ea"/>
-              </a:rPr>
-              <a:t>To address this issue, we propose a Machine Learning-based Flight Delay Prediction System that can analyze historical flight data and predict whether a flight is likely to be delayed.</a:t>
+              <a:t>To address this issue, we propose Aerosight — a Machine Learning-based Flight Delay Prediction System that analyzes historical data, integrates live external APIs, and predicts whether a flight is likely to be delayed.</a:t>
             </a:r>
-            <a:endParaRPr>
-              <a:sym typeface="+mn-ea"/>
-            </a:endParaRPr>
+          </a:p>
+          <a:p/>
+          <a:p>
+            <a:r>
+              <a:t>Key Technical Components:</a:t>
+            </a:r>
           </a:p>
           <a:p>
-            <a:pPr marL="173355" indent="-173355">
-              <a:spcAft>
-                <a:spcPts val="800"/>
-              </a:spcAft>
-              <a:buFont typeface="Arial" panose="020B0604020202020204" pitchFamily="34" charset="0"/>
-              <a:buChar char="•"/>
-            </a:pPr>
             <a:r>
-              <a:rPr>
-                <a:sym typeface="+mn-ea"/>
-              </a:rPr>
-              <a:t>The system uses:</a:t>
+              <a:t>• Gradient Boosting (XGBoost) Machine Learning Engine (replaces legacy Random Forest)</a:t>
             </a:r>
-            <a:endParaRPr>
-              <a:sym typeface="+mn-ea"/>
-            </a:endParaRPr>
           </a:p>
           <a:p>
-            <a:pPr marL="0" indent="457200">
-              <a:spcAft>
-                <a:spcPts val="800"/>
-              </a:spcAft>
-              <a:buFont typeface="Arial" panose="020B0604020202020204" pitchFamily="34" charset="0"/>
-              <a:buNone/>
-            </a:pPr>
             <a:r>
-              <a:rPr>
-                <a:sym typeface="+mn-ea"/>
-              </a:rPr>
-              <a:t>• Random Forest Machine Learning Algorithm</a:t>
+              <a:t>• Live Weather API Integration (Open-Meteo) fetching 25 real-time features</a:t>
             </a:r>
-            <a:endParaRPr>
-              <a:sym typeface="+mn-ea"/>
-            </a:endParaRPr>
           </a:p>
           <a:p>
-            <a:pPr marL="0" indent="457200">
-              <a:spcAft>
-                <a:spcPts val="800"/>
-              </a:spcAft>
-              <a:buFont typeface="Arial" panose="020B0604020202020204" pitchFamily="34" charset="0"/>
-              <a:buNone/>
-            </a:pPr>
             <a:r>
-              <a:rPr>
-                <a:sym typeface="+mn-ea"/>
-              </a:rPr>
-              <a:t>• Historical Flight Data Analysis</a:t>
+              <a:t>• Interactive Route Map (Folium) with risk-coded paths &amp; airport weather details</a:t>
             </a:r>
-            <a:endParaRPr>
-              <a:sym typeface="+mn-ea"/>
-            </a:endParaRPr>
           </a:p>
           <a:p>
-            <a:pPr marL="0" indent="457200">
-              <a:spcAft>
-                <a:spcPts val="800"/>
-              </a:spcAft>
-              <a:buFont typeface="Arial" panose="020B0604020202020204" pitchFamily="34" charset="0"/>
-              <a:buNone/>
-            </a:pPr>
             <a:r>
-              <a:rPr>
-                <a:sym typeface="+mn-ea"/>
-              </a:rPr>
-              <a:t>• Data Preprocessing and Visualization</a:t>
+              <a:t>• Streamlit Interactive Dashboard (with Dark/Light Mode settings)</a:t>
             </a:r>
-            <a:endParaRPr>
-              <a:sym typeface="+mn-ea"/>
-            </a:endParaRPr>
           </a:p>
+          <a:p/>
           <a:p>
-            <a:pPr marL="0" indent="457200">
-              <a:spcAft>
-                <a:spcPts val="800"/>
-              </a:spcAft>
-              <a:buFont typeface="Arial" panose="020B0604020202020204" pitchFamily="34" charset="0"/>
-              <a:buNone/>
-            </a:pPr>
             <a:r>
-              <a:rPr>
-                <a:sym typeface="+mn-ea"/>
-              </a:rPr>
-              <a:t>• Streamlit Interactive Dashboard</a:t>
+              <a:t>Users enter flight parameters (airline, route, schedule) and get real-time delay probability percentages, a gauge chart, and a plain-English verdict.</a:t>
             </a:r>
-            <a:endParaRPr>
-              <a:sym typeface="+mn-ea"/>
-            </a:endParaRPr>
-          </a:p>
-          <a:p>
-            <a:pPr marL="173355" indent="-173355">
-              <a:spcAft>
-                <a:spcPts val="800"/>
-              </a:spcAft>
-              <a:buFont typeface="Arial" panose="020B0604020202020204" pitchFamily="34" charset="0"/>
-              <a:buChar char="•"/>
-            </a:pPr>
-            <a:r>
-              <a:rPr>
-                <a:sym typeface="+mn-ea"/>
-              </a:rPr>
-              <a:t>Users can enter flight details such as airline, source airport, destination, departure time, and day of travel to get instant delay predictions.</a:t>
-            </a:r>
-            <a:endParaRPr lang="en-US"/>
           </a:p>
         </p:txBody>
       </p:sp>
@@ -5755,110 +5662,35 @@
           </a:bodyPr>
           <a:lstStyle/>
           <a:p>
-            <a:pPr marL="0" indent="0">
-              <a:spcAft>
-                <a:spcPts val="800"/>
-              </a:spcAft>
-              <a:buFont typeface="Arial" panose="020B0604020202020204" pitchFamily="34" charset="0"/>
-              <a:buNone/>
-            </a:pPr>
             <a:r>
-              <a:rPr>
-                <a:sym typeface="+mn-ea"/>
-              </a:rPr>
-              <a:t>• Real-time Flight Tracking</a:t>
+              <a:t>The system has a clear path for expansion to become an industry-grade aerospace operational dashboard:</a:t>
             </a:r>
-            <a:endParaRPr>
-              <a:sym typeface="+mn-ea"/>
-            </a:endParaRPr>
+          </a:p>
+          <a:p/>
+          <a:p>
+            <a:r>
+              <a:t>• Real-time Flight Tracking API integration (e.g. FlightAware API) for active airborne flights</a:t>
+            </a:r>
           </a:p>
           <a:p>
-            <a:pPr marL="0" indent="0">
-              <a:spcAft>
-                <a:spcPts val="800"/>
-              </a:spcAft>
-              <a:buFont typeface="Arial" panose="020B0604020202020204" pitchFamily="34" charset="0"/>
-              <a:buNone/>
-            </a:pPr>
             <a:r>
-              <a:rPr>
-                <a:sym typeface="+mn-ea"/>
-              </a:rPr>
-              <a:t>• Weather API Integration</a:t>
+              <a:t>• Mobile Application Support (iOS &amp; Android) with push notifications for delay updates</a:t>
             </a:r>
-            <a:endParaRPr>
-              <a:sym typeface="+mn-ea"/>
-            </a:endParaRPr>
           </a:p>
           <a:p>
-            <a:pPr marL="0" indent="0">
-              <a:spcAft>
-                <a:spcPts val="800"/>
-              </a:spcAft>
-              <a:buFont typeface="Arial" panose="020B0604020202020204" pitchFamily="34" charset="0"/>
-              <a:buNone/>
-            </a:pPr>
             <a:r>
-              <a:rPr>
-                <a:sym typeface="+mn-ea"/>
-              </a:rPr>
-              <a:t>• Delay Probability Percentage</a:t>
+              <a:t>• Advanced AI Models (LSTMs or Transformers) for forecasting downstream propagation delays</a:t>
             </a:r>
-            <a:endParaRPr>
-              <a:sym typeface="+mn-ea"/>
-            </a:endParaRPr>
           </a:p>
           <a:p>
-            <a:pPr marL="0" indent="0">
-              <a:spcAft>
-                <a:spcPts val="800"/>
-              </a:spcAft>
-              <a:buFont typeface="Arial" panose="020B0604020202020204" pitchFamily="34" charset="0"/>
-              <a:buNone/>
-            </a:pPr>
             <a:r>
-              <a:rPr>
-                <a:sym typeface="+mn-ea"/>
-              </a:rPr>
-              <a:t>• Mobile Application Support</a:t>
+              <a:t>• Airport Congestion &amp; Gate Allocation Analysis using flight scheduling graphs</a:t>
             </a:r>
-            <a:endParaRPr>
-              <a:sym typeface="+mn-ea"/>
-            </a:endParaRPr>
           </a:p>
           <a:p>
-            <a:pPr marL="0" indent="0">
-              <a:spcAft>
-                <a:spcPts val="800"/>
-              </a:spcAft>
-              <a:buFont typeface="Arial" panose="020B0604020202020204" pitchFamily="34" charset="0"/>
-              <a:buNone/>
-            </a:pPr>
             <a:r>
-              <a:rPr>
-                <a:sym typeface="+mn-ea"/>
-              </a:rPr>
-              <a:t>• Advanced AI Models</a:t>
+              <a:t>• Carbon Emission Tracking per flight based on routing, aircraft type, and delay duration</a:t>
             </a:r>
-            <a:endParaRPr>
-              <a:sym typeface="+mn-ea"/>
-            </a:endParaRPr>
-          </a:p>
-          <a:p>
-            <a:pPr marL="0" indent="0">
-              <a:spcAft>
-                <a:spcPts val="800"/>
-              </a:spcAft>
-              <a:buFont typeface="Arial" panose="020B0604020202020204" pitchFamily="34" charset="0"/>
-              <a:buNone/>
-            </a:pPr>
-            <a:r>
-              <a:rPr>
-                <a:sym typeface="+mn-ea"/>
-              </a:rPr>
-              <a:t>• Airport Congestion Analysis</a:t>
-            </a:r>
-            <a:endParaRPr lang="en-US"/>
           </a:p>
         </p:txBody>
       </p:sp>
@@ -6184,98 +6016,24 @@
           </a:bodyPr>
           <a:lstStyle/>
           <a:p>
-            <a:pPr marL="285750" lvl="0" indent="-285750">
-              <a:spcAft>
-                <a:spcPts val="800"/>
-              </a:spcAft>
-              <a:buFont typeface="Arial" panose="020B0604020202020204" pitchFamily="34" charset="0"/>
-              <a:buChar char="•"/>
-            </a:pPr>
             <a:r>
-              <a:rPr>
-                <a:sym typeface="+mn-ea"/>
-              </a:rPr>
-              <a:t>The Flight Delay Prediction System successfully predicts whether a flight is likely to be delayed using Machine Learning.</a:t>
+              <a:t>• Aerosight successfully predicts flight delays using a high-precision Gradient Boosting classifier.</a:t>
             </a:r>
-            <a:endParaRPr>
-              <a:sym typeface="+mn-ea"/>
-            </a:endParaRPr>
           </a:p>
           <a:p>
-            <a:pPr marL="285750" indent="-285750">
-              <a:spcAft>
-                <a:spcPts val="800"/>
-              </a:spcAft>
-              <a:buFont typeface="Arial" panose="020B0604020202020204" pitchFamily="34" charset="0"/>
-              <a:buChar char="•"/>
-            </a:pPr>
             <a:r>
-              <a:rPr lang="en-US"/>
-              <a:t>By streamlining translation, data extraction, and analysis, businesses can make informed decisions more efficiently.</a:t>
+              <a:t>• By streamlining real-time weather integration and predictive modeling, stakeholders can make informed decisions more efficiently.</a:t>
             </a:r>
-            <a:endParaRPr lang="en-US"/>
           </a:p>
           <a:p>
-            <a:pPr marL="285750" indent="-285750">
-              <a:spcAft>
-                <a:spcPts val="800"/>
-              </a:spcAft>
-              <a:buFont typeface="Arial" panose="020B0604020202020204" pitchFamily="34" charset="0"/>
-              <a:buChar char="•"/>
-            </a:pPr>
             <a:r>
-              <a:rPr>
-                <a:sym typeface="+mn-ea"/>
-              </a:rPr>
-              <a:t>The project improves decision-making for passengers, airlines, and airport authorities through predictive analytics and visualization.</a:t>
+              <a:t>• The project improves decision-making for passengers, airlines, and airport authorities through predictive analytics and visualizations.</a:t>
             </a:r>
-            <a:endParaRPr>
-              <a:sym typeface="+mn-ea"/>
-            </a:endParaRPr>
           </a:p>
           <a:p>
-            <a:pPr marL="285750" indent="-285750">
-              <a:spcAft>
-                <a:spcPts val="800"/>
-              </a:spcAft>
-              <a:buFont typeface="Arial" panose="020B0604020202020204" pitchFamily="34" charset="0"/>
-              <a:buChar char="•"/>
-            </a:pPr>
             <a:r>
-              <a:rPr lang="en-US" altLang="en-US">
-                <a:sym typeface="+mn-ea"/>
-              </a:rPr>
-              <a:t>The project demonstrates how Machine Learning can be effectively applied in the aerospace industry to solve real-world problems and improve passenger travel experience through accurate delay prediction.</a:t>
+              <a:t>• The project demonstrates how ML and live API integrations can be effectively applied in the aerospace industry to solve real-world problems.</a:t>
             </a:r>
-            <a:endParaRPr lang="en-US" altLang="en-US">
-              <a:sym typeface="+mn-ea"/>
-            </a:endParaRPr>
-          </a:p>
-          <a:p>
-            <a:pPr marL="173990" indent="-173990">
-              <a:spcAft>
-                <a:spcPts val="800"/>
-              </a:spcAft>
-              <a:buFont typeface="Arial" panose="020B0604020202020204" pitchFamily="34" charset="0"/>
-              <a:buChar char="•"/>
-            </a:pPr>
-            <a:endParaRPr lang="en-US" altLang="en-US">
-              <a:sym typeface="+mn-ea"/>
-            </a:endParaRPr>
-          </a:p>
-          <a:p>
-            <a:pPr marL="0" indent="0">
-              <a:spcAft>
-                <a:spcPts val="800"/>
-              </a:spcAft>
-              <a:buFont typeface="Arial" panose="020B0604020202020204" pitchFamily="34" charset="0"/>
-              <a:buNone/>
-            </a:pPr>
-            <a:r>
-              <a:rPr lang="en-US"/>
-              <a:t> </a:t>
-            </a:r>
-            <a:endParaRPr lang="en-US"/>
           </a:p>
         </p:txBody>
       </p:sp>

</xml_diff>